<commit_message>
actualizo cronograma, hojas de ruta y ppt 5
</commit_message>
<xml_diff>
--- a/clase2/Tidymodels.pptx
+++ b/clase2/Tidymodels.pptx
@@ -8686,8 +8686,8 @@
         </p:nvGrpSpPr>
         <p:grpSpPr>
           <a:xfrm>
-            <a:off x="861935" y="1743856"/>
-            <a:ext cx="1648919" cy="1307579"/>
+            <a:off x="861934" y="1743856"/>
+            <a:ext cx="1728000" cy="1307579"/>
             <a:chOff x="968114" y="1264171"/>
             <a:chExt cx="1648919" cy="1307579"/>
           </a:xfrm>
@@ -8951,7 +8951,7 @@
         <p:grpSpPr>
           <a:xfrm>
             <a:off x="2710722" y="1743856"/>
-            <a:ext cx="1661410" cy="1307579"/>
+            <a:ext cx="1728000" cy="1307579"/>
             <a:chOff x="2834390" y="1264171"/>
             <a:chExt cx="1661410" cy="1307579"/>
           </a:xfrm>
@@ -9233,7 +9233,7 @@
         <p:grpSpPr>
           <a:xfrm>
             <a:off x="4572000" y="1743856"/>
-            <a:ext cx="1648920" cy="1307579"/>
+            <a:ext cx="1728000" cy="1307579"/>
             <a:chOff x="4725648" y="1264171"/>
             <a:chExt cx="1648920" cy="1307579"/>
           </a:xfrm>
@@ -9293,7 +9293,7 @@
                   </a:solidFill>
                   <a:latin typeface="Proxima Nova" panose="020B0604020202020204" charset="0"/>
                 </a:rPr>
-                <a:t>nearest_neighbor</a:t>
+                <a:t>linear_reg</a:t>
               </a:r>
               <a:r>
                 <a:rPr lang="es-MX" sz="1200" dirty="0">
@@ -9302,7 +9302,7 @@
                   </a:solidFill>
                   <a:latin typeface="Proxima Nova" panose="020B0604020202020204" charset="0"/>
                 </a:rPr>
-                <a:t>()</a:t>
+                <a:t>(mixture=1)</a:t>
               </a:r>
               <a:endParaRPr lang="es-AR" sz="1200" dirty="0">
                 <a:solidFill>
@@ -9386,7 +9386,7 @@
                   </a:solidFill>
                   <a:latin typeface="Proxima Nova" panose="020B0604020202020204" charset="0"/>
                 </a:rPr>
-                <a:t>kknn</a:t>
+                <a:t>glmnet</a:t>
               </a:r>
               <a:r>
                 <a:rPr lang="es-MX" sz="1200" dirty="0">
@@ -9479,7 +9479,7 @@
                   </a:solidFill>
                   <a:latin typeface="Proxima Nova" panose="020B0604020202020204" charset="0"/>
                 </a:rPr>
-                <a:t>classification</a:t>
+                <a:t>regression</a:t>
               </a:r>
               <a:r>
                 <a:rPr lang="es-MX" sz="1000" dirty="0">
@@ -9515,7 +9515,7 @@
         <p:grpSpPr>
           <a:xfrm>
             <a:off x="6420787" y="1743856"/>
-            <a:ext cx="1648920" cy="1307579"/>
+            <a:ext cx="1728000" cy="1307579"/>
             <a:chOff x="6526966" y="1264171"/>
             <a:chExt cx="1648920" cy="1307579"/>
           </a:xfrm>
@@ -9534,8 +9534,8 @@
           </p:nvSpPr>
           <p:spPr>
             <a:xfrm>
-              <a:off x="6526967" y="1264171"/>
-              <a:ext cx="1648919" cy="359764"/>
+              <a:off x="6526966" y="1264171"/>
+              <a:ext cx="1648800" cy="359764"/>
             </a:xfrm>
             <a:prstGeom prst="roundRect">
               <a:avLst/>
@@ -9575,7 +9575,7 @@
                   </a:solidFill>
                   <a:latin typeface="Proxima Nova" panose="020B0604020202020204" charset="0"/>
                 </a:rPr>
-                <a:t>discrim_linear</a:t>
+                <a:t>logistic_reg</a:t>
               </a:r>
               <a:r>
                 <a:rPr lang="es-MX" sz="1200" dirty="0">
@@ -9584,7 +9584,7 @@
                   </a:solidFill>
                   <a:latin typeface="Proxima Nova" panose="020B0604020202020204" charset="0"/>
                 </a:rPr>
-                <a:t>()</a:t>
+                <a:t>(mixture=1)</a:t>
               </a:r>
               <a:endParaRPr lang="es-AR" sz="1200" dirty="0">
                 <a:solidFill>
@@ -9659,7 +9659,25 @@
                   </a:solidFill>
                   <a:latin typeface="Proxima Nova" panose="020B0604020202020204" charset="0"/>
                 </a:rPr>
-                <a:t>(‘MASS’)</a:t>
+                <a:t>(‘</a:t>
+              </a:r>
+              <a:r>
+                <a:rPr lang="es-MX" sz="1200" dirty="0" err="1">
+                  <a:solidFill>
+                    <a:schemeClr val="accent2"/>
+                  </a:solidFill>
+                  <a:latin typeface="Proxima Nova" panose="020B0604020202020204" charset="0"/>
+                </a:rPr>
+                <a:t>glmnet</a:t>
+              </a:r>
+              <a:r>
+                <a:rPr lang="es-MX" sz="1200" dirty="0">
+                  <a:solidFill>
+                    <a:schemeClr val="accent2"/>
+                  </a:solidFill>
+                  <a:latin typeface="Proxima Nova" panose="020B0604020202020204" charset="0"/>
+                </a:rPr>
+                <a:t>’)</a:t>
               </a:r>
               <a:endParaRPr lang="es-AR" sz="1200" dirty="0">
                 <a:solidFill>
@@ -9781,8 +9799,8 @@
         </p:nvCxnSpPr>
         <p:spPr>
           <a:xfrm flipH="1">
-            <a:off x="1686395" y="876924"/>
-            <a:ext cx="2628274" cy="866932"/>
+            <a:off x="1725934" y="876924"/>
+            <a:ext cx="2588735" cy="866932"/>
           </a:xfrm>
           <a:prstGeom prst="straightConnector1">
             <a:avLst/>
@@ -9823,8 +9841,8 @@
         </p:nvCxnSpPr>
         <p:spPr>
           <a:xfrm flipH="1">
-            <a:off x="3535182" y="876924"/>
-            <a:ext cx="779487" cy="866932"/>
+            <a:off x="3568226" y="876924"/>
+            <a:ext cx="746443" cy="866932"/>
           </a:xfrm>
           <a:prstGeom prst="straightConnector1">
             <a:avLst/>
@@ -9866,7 +9884,7 @@
         <p:spPr>
           <a:xfrm>
             <a:off x="4314669" y="876924"/>
-            <a:ext cx="1081792" cy="866932"/>
+            <a:ext cx="1121332" cy="866932"/>
           </a:xfrm>
           <a:prstGeom prst="straightConnector1">
             <a:avLst/>
@@ -9908,7 +9926,7 @@
         <p:spPr>
           <a:xfrm>
             <a:off x="4314669" y="876924"/>
-            <a:ext cx="2930579" cy="866932"/>
+            <a:ext cx="2970055" cy="866932"/>
           </a:xfrm>
           <a:prstGeom prst="straightConnector1">
             <a:avLst/>
@@ -10151,7 +10169,7 @@
         </p:nvSpPr>
         <p:spPr>
           <a:xfrm>
-            <a:off x="3490209" y="374753"/>
+            <a:off x="3747539" y="359475"/>
             <a:ext cx="1648919" cy="502171"/>
           </a:xfrm>
           <a:prstGeom prst="roundRect">
@@ -10217,7 +10235,7 @@
         </p:nvGrpSpPr>
         <p:grpSpPr>
           <a:xfrm>
-            <a:off x="861935" y="1743856"/>
+            <a:off x="1906240" y="1728578"/>
             <a:ext cx="1648919" cy="1307579"/>
             <a:chOff x="968114" y="1264171"/>
             <a:chExt cx="1648919" cy="1307579"/>
@@ -10436,7 +10454,7 @@
         </p:nvGrpSpPr>
         <p:grpSpPr>
           <a:xfrm>
-            <a:off x="2710722" y="1743856"/>
+            <a:off x="3755027" y="1728578"/>
             <a:ext cx="1661410" cy="1307579"/>
             <a:chOff x="2834390" y="1264171"/>
             <a:chExt cx="1661410" cy="1307579"/>
@@ -10664,7 +10682,7 @@
         </p:nvGrpSpPr>
         <p:grpSpPr>
           <a:xfrm>
-            <a:off x="4572001" y="1743856"/>
+            <a:off x="5616306" y="1728578"/>
             <a:ext cx="1648919" cy="826958"/>
             <a:chOff x="4725649" y="1264171"/>
             <a:chExt cx="1648919" cy="826958"/>
@@ -10803,159 +10821,6 @@
           </p:txBody>
         </p:sp>
       </p:grpSp>
-      <p:grpSp>
-        <p:nvGrpSpPr>
-          <p:cNvPr id="22" name="Grupo 21">
-            <a:extLst>
-              <a:ext uri="{FF2B5EF4-FFF2-40B4-BE49-F238E27FC236}">
-                <a16:creationId xmlns:a16="http://schemas.microsoft.com/office/drawing/2014/main" id="{93F3B69B-5BB9-407C-B349-06ABB94A0838}"/>
-              </a:ext>
-            </a:extLst>
-          </p:cNvPr>
-          <p:cNvGrpSpPr/>
-          <p:nvPr/>
-        </p:nvGrpSpPr>
-        <p:grpSpPr>
-          <a:xfrm>
-            <a:off x="6420788" y="1743856"/>
-            <a:ext cx="1648919" cy="826958"/>
-            <a:chOff x="6526967" y="1264171"/>
-            <a:chExt cx="1648919" cy="826958"/>
-          </a:xfrm>
-        </p:grpSpPr>
-        <p:sp>
-          <p:nvSpPr>
-            <p:cNvPr id="19" name="Rectángulo: esquinas redondeadas 18">
-              <a:extLst>
-                <a:ext uri="{FF2B5EF4-FFF2-40B4-BE49-F238E27FC236}">
-                  <a16:creationId xmlns:a16="http://schemas.microsoft.com/office/drawing/2014/main" id="{509970EA-0F7C-41A4-816B-9275D8C2E661}"/>
-                </a:ext>
-              </a:extLst>
-            </p:cNvPr>
-            <p:cNvSpPr/>
-            <p:nvPr/>
-          </p:nvSpPr>
-          <p:spPr>
-            <a:xfrm>
-              <a:off x="6526967" y="1264171"/>
-              <a:ext cx="1648919" cy="359764"/>
-            </a:xfrm>
-            <a:prstGeom prst="roundRect">
-              <a:avLst/>
-            </a:prstGeom>
-            <a:noFill/>
-            <a:ln>
-              <a:solidFill>
-                <a:schemeClr val="accent3"/>
-              </a:solidFill>
-            </a:ln>
-          </p:spPr>
-          <p:style>
-            <a:lnRef idx="2">
-              <a:schemeClr val="accent1">
-                <a:shade val="50000"/>
-              </a:schemeClr>
-            </a:lnRef>
-            <a:fillRef idx="1">
-              <a:schemeClr val="accent1"/>
-            </a:fillRef>
-            <a:effectRef idx="0">
-              <a:schemeClr val="accent1"/>
-            </a:effectRef>
-            <a:fontRef idx="minor">
-              <a:schemeClr val="lt1"/>
-            </a:fontRef>
-          </p:style>
-          <p:txBody>
-            <a:bodyPr rtlCol="0" anchor="ctr"/>
-            <a:lstStyle/>
-            <a:p>
-              <a:pPr algn="ctr"/>
-              <a:r>
-                <a:rPr lang="es-MX" dirty="0" err="1">
-                  <a:solidFill>
-                    <a:schemeClr val="accent2"/>
-                  </a:solidFill>
-                  <a:latin typeface="Proxima Nova" panose="020B0604020202020204" charset="0"/>
-                </a:rPr>
-                <a:t>lda_rec</a:t>
-              </a:r>
-              <a:endParaRPr lang="es-AR" dirty="0">
-                <a:solidFill>
-                  <a:schemeClr val="accent2"/>
-                </a:solidFill>
-                <a:latin typeface="Proxima Nova" panose="020B0604020202020204" charset="0"/>
-              </a:endParaRPr>
-            </a:p>
-          </p:txBody>
-        </p:sp>
-        <p:sp>
-          <p:nvSpPr>
-            <p:cNvPr id="20" name="Rectángulo: esquinas redondeadas 19">
-              <a:extLst>
-                <a:ext uri="{FF2B5EF4-FFF2-40B4-BE49-F238E27FC236}">
-                  <a16:creationId xmlns:a16="http://schemas.microsoft.com/office/drawing/2014/main" id="{B6146A01-ADA9-4A45-A6F7-552D9EE78478}"/>
-                </a:ext>
-              </a:extLst>
-            </p:cNvPr>
-            <p:cNvSpPr/>
-            <p:nvPr/>
-          </p:nvSpPr>
-          <p:spPr>
-            <a:xfrm>
-              <a:off x="6526967" y="1731365"/>
-              <a:ext cx="1648919" cy="359764"/>
-            </a:xfrm>
-            <a:prstGeom prst="roundRect">
-              <a:avLst/>
-            </a:prstGeom>
-            <a:noFill/>
-            <a:ln>
-              <a:solidFill>
-                <a:schemeClr val="accent3"/>
-              </a:solidFill>
-            </a:ln>
-          </p:spPr>
-          <p:style>
-            <a:lnRef idx="2">
-              <a:schemeClr val="accent1">
-                <a:shade val="50000"/>
-              </a:schemeClr>
-            </a:lnRef>
-            <a:fillRef idx="1">
-              <a:schemeClr val="accent1"/>
-            </a:fillRef>
-            <a:effectRef idx="0">
-              <a:schemeClr val="accent1"/>
-            </a:effectRef>
-            <a:fontRef idx="minor">
-              <a:schemeClr val="lt1"/>
-            </a:fontRef>
-          </p:style>
-          <p:txBody>
-            <a:bodyPr rtlCol="0" anchor="ctr"/>
-            <a:lstStyle/>
-            <a:p>
-              <a:pPr algn="ctr"/>
-              <a:r>
-                <a:rPr lang="es-MX" dirty="0">
-                  <a:solidFill>
-                    <a:schemeClr val="accent2"/>
-                  </a:solidFill>
-                  <a:latin typeface="Proxima Nova" panose="020B0604020202020204" charset="0"/>
-                </a:rPr>
-                <a:t>lm_rec2</a:t>
-              </a:r>
-              <a:endParaRPr lang="es-AR" dirty="0">
-                <a:solidFill>
-                  <a:schemeClr val="accent2"/>
-                </a:solidFill>
-                <a:latin typeface="Proxima Nova" panose="020B0604020202020204" charset="0"/>
-              </a:endParaRPr>
-            </a:p>
-          </p:txBody>
-        </p:sp>
-      </p:grpSp>
       <p:cxnSp>
         <p:nvCxnSpPr>
           <p:cNvPr id="24" name="Conector recto de flecha 23">
@@ -10973,8 +10838,8 @@
         </p:nvCxnSpPr>
         <p:spPr>
           <a:xfrm flipH="1">
-            <a:off x="1686395" y="876924"/>
-            <a:ext cx="2628274" cy="866932"/>
+            <a:off x="2730700" y="861646"/>
+            <a:ext cx="1841299" cy="866932"/>
           </a:xfrm>
           <a:prstGeom prst="straightConnector1">
             <a:avLst/>
@@ -11014,9 +10879,9 @@
           <p:nvPr/>
         </p:nvCxnSpPr>
         <p:spPr>
-          <a:xfrm flipH="1">
-            <a:off x="3535182" y="876924"/>
-            <a:ext cx="779487" cy="866932"/>
+          <a:xfrm>
+            <a:off x="4571999" y="861646"/>
+            <a:ext cx="7488" cy="866932"/>
           </a:xfrm>
           <a:prstGeom prst="straightConnector1">
             <a:avLst/>
@@ -11057,50 +10922,8 @@
         </p:nvCxnSpPr>
         <p:spPr>
           <a:xfrm>
-            <a:off x="4314669" y="876924"/>
-            <a:ext cx="1081792" cy="866932"/>
-          </a:xfrm>
-          <a:prstGeom prst="straightConnector1">
-            <a:avLst/>
-          </a:prstGeom>
-          <a:ln>
-            <a:tailEnd type="triangle"/>
-          </a:ln>
-        </p:spPr>
-        <p:style>
-          <a:lnRef idx="1">
-            <a:schemeClr val="accent1"/>
-          </a:lnRef>
-          <a:fillRef idx="0">
-            <a:schemeClr val="accent1"/>
-          </a:fillRef>
-          <a:effectRef idx="0">
-            <a:schemeClr val="accent1"/>
-          </a:effectRef>
-          <a:fontRef idx="minor">
-            <a:schemeClr val="tx1"/>
-          </a:fontRef>
-        </p:style>
-      </p:cxnSp>
-      <p:cxnSp>
-        <p:nvCxnSpPr>
-          <p:cNvPr id="30" name="Conector recto de flecha 29">
-            <a:extLst>
-              <a:ext uri="{FF2B5EF4-FFF2-40B4-BE49-F238E27FC236}">
-                <a16:creationId xmlns:a16="http://schemas.microsoft.com/office/drawing/2014/main" id="{CC6DCB1B-DB56-452B-B01C-F32AFD4F6176}"/>
-              </a:ext>
-            </a:extLst>
-          </p:cNvPr>
-          <p:cNvCxnSpPr>
-            <a:stCxn id="5" idx="2"/>
-            <a:endCxn id="19" idx="0"/>
-          </p:cNvCxnSpPr>
-          <p:nvPr/>
-        </p:nvCxnSpPr>
-        <p:spPr>
-          <a:xfrm>
-            <a:off x="4314669" y="876924"/>
-            <a:ext cx="2930579" cy="866932"/>
+            <a:off x="4571999" y="861646"/>
+            <a:ext cx="1868767" cy="866932"/>
           </a:xfrm>
           <a:prstGeom prst="straightConnector1">
             <a:avLst/>
@@ -11138,7 +10961,7 @@
         </p:nvSpPr>
         <p:spPr>
           <a:xfrm>
-            <a:off x="861934" y="3172292"/>
+            <a:off x="1906239" y="3157014"/>
             <a:ext cx="1648919" cy="359764"/>
           </a:xfrm>
           <a:prstGeom prst="roundRect">
@@ -11204,7 +11027,7 @@
         </p:nvSpPr>
         <p:spPr>
           <a:xfrm>
-            <a:off x="1094283" y="3846562"/>
+            <a:off x="753256" y="3749126"/>
             <a:ext cx="7637487" cy="1034899"/>
           </a:xfrm>
           <a:prstGeom prst="rect">
@@ -11433,7 +11256,7 @@
         </p:nvSpPr>
         <p:spPr>
           <a:xfrm>
-            <a:off x="3625116" y="1170738"/>
+            <a:off x="3625116" y="1305648"/>
             <a:ext cx="4527028" cy="2650726"/>
           </a:xfrm>
           <a:prstGeom prst="rect">
@@ -11824,7 +11647,7 @@
         </p:nvGrpSpPr>
         <p:grpSpPr>
           <a:xfrm>
-            <a:off x="1474028" y="419724"/>
+            <a:off x="1474028" y="854434"/>
             <a:ext cx="1648920" cy="3144289"/>
             <a:chOff x="1219195" y="816963"/>
             <a:chExt cx="1648920" cy="3144289"/>
@@ -12359,7 +12182,7 @@
         </p:nvSpPr>
         <p:spPr>
           <a:xfrm>
-            <a:off x="3329403" y="382250"/>
+            <a:off x="3329403" y="914396"/>
             <a:ext cx="1947600" cy="509666"/>
           </a:xfrm>
           <a:prstGeom prst="roundRect">
@@ -12434,7 +12257,7 @@
         </p:nvSpPr>
         <p:spPr>
           <a:xfrm>
-            <a:off x="1058394" y="1823802"/>
+            <a:off x="1058394" y="2355948"/>
             <a:ext cx="1948723" cy="509666"/>
           </a:xfrm>
           <a:prstGeom prst="roundRect">
@@ -12509,7 +12332,7 @@
         </p:nvSpPr>
         <p:spPr>
           <a:xfrm>
-            <a:off x="3329403" y="1823802"/>
+            <a:off x="3329403" y="2355948"/>
             <a:ext cx="1948723" cy="509666"/>
           </a:xfrm>
           <a:prstGeom prst="roundRect">
@@ -12584,7 +12407,7 @@
         </p:nvSpPr>
         <p:spPr>
           <a:xfrm>
-            <a:off x="5600413" y="1823802"/>
+            <a:off x="5600413" y="2355948"/>
             <a:ext cx="1948723" cy="509666"/>
           </a:xfrm>
           <a:prstGeom prst="roundRect">
@@ -12659,7 +12482,7 @@
         </p:nvSpPr>
         <p:spPr>
           <a:xfrm>
-            <a:off x="1058394" y="2470878"/>
+            <a:off x="1058394" y="3003024"/>
             <a:ext cx="1948723" cy="509666"/>
           </a:xfrm>
           <a:prstGeom prst="roundRect">
@@ -12734,7 +12557,7 @@
         </p:nvSpPr>
         <p:spPr>
           <a:xfrm>
-            <a:off x="3329403" y="2470878"/>
+            <a:off x="3329403" y="3003024"/>
             <a:ext cx="1948723" cy="509666"/>
           </a:xfrm>
           <a:prstGeom prst="roundRect">
@@ -12809,7 +12632,7 @@
         </p:nvSpPr>
         <p:spPr>
           <a:xfrm>
-            <a:off x="5600413" y="2470878"/>
+            <a:off x="5600413" y="3003024"/>
             <a:ext cx="1948723" cy="509666"/>
           </a:xfrm>
           <a:prstGeom prst="roundRect">
@@ -12884,7 +12707,7 @@
         </p:nvSpPr>
         <p:spPr>
           <a:xfrm>
-            <a:off x="1058394" y="3117954"/>
+            <a:off x="1058394" y="3650100"/>
             <a:ext cx="1948723" cy="509666"/>
           </a:xfrm>
           <a:prstGeom prst="roundRect">
@@ -12959,7 +12782,7 @@
         </p:nvSpPr>
         <p:spPr>
           <a:xfrm>
-            <a:off x="3329403" y="3117954"/>
+            <a:off x="3329403" y="3650100"/>
             <a:ext cx="1948723" cy="509666"/>
           </a:xfrm>
           <a:prstGeom prst="roundRect">
@@ -13034,7 +12857,7 @@
         </p:nvSpPr>
         <p:spPr>
           <a:xfrm>
-            <a:off x="5600413" y="3117954"/>
+            <a:off x="5600413" y="3650100"/>
             <a:ext cx="1948723" cy="509666"/>
           </a:xfrm>
           <a:prstGeom prst="roundRect">
@@ -13112,7 +12935,7 @@
         </p:nvCxnSpPr>
         <p:spPr>
           <a:xfrm flipH="1">
-            <a:off x="2032756" y="891916"/>
+            <a:off x="2032756" y="1424062"/>
             <a:ext cx="2270447" cy="931886"/>
           </a:xfrm>
           <a:prstGeom prst="straightConnector1">
@@ -13154,7 +12977,7 @@
         </p:nvCxnSpPr>
         <p:spPr>
           <a:xfrm>
-            <a:off x="4303203" y="891916"/>
+            <a:off x="4303203" y="1424062"/>
             <a:ext cx="562" cy="931886"/>
           </a:xfrm>
           <a:prstGeom prst="straightConnector1">
@@ -13196,7 +13019,7 @@
         </p:nvCxnSpPr>
         <p:spPr>
           <a:xfrm>
-            <a:off x="4303203" y="891916"/>
+            <a:off x="4303203" y="1424062"/>
             <a:ext cx="2271572" cy="931886"/>
           </a:xfrm>
           <a:prstGeom prst="straightConnector1">
@@ -13278,7 +13101,7 @@
         </p:nvSpPr>
         <p:spPr>
           <a:xfrm>
-            <a:off x="3329403" y="382250"/>
+            <a:off x="3329403" y="876921"/>
             <a:ext cx="1947600" cy="509666"/>
           </a:xfrm>
           <a:prstGeom prst="roundRect">
@@ -13353,7 +13176,7 @@
         </p:nvSpPr>
         <p:spPr>
           <a:xfrm>
-            <a:off x="1058394" y="1823802"/>
+            <a:off x="1058394" y="2318473"/>
             <a:ext cx="1948723" cy="509666"/>
           </a:xfrm>
           <a:prstGeom prst="roundRect">
@@ -13419,7 +13242,7 @@
         </p:nvSpPr>
         <p:spPr>
           <a:xfrm>
-            <a:off x="3329403" y="1823802"/>
+            <a:off x="3329403" y="2318473"/>
             <a:ext cx="1948723" cy="509666"/>
           </a:xfrm>
           <a:prstGeom prst="roundRect">
@@ -13485,7 +13308,7 @@
         </p:nvSpPr>
         <p:spPr>
           <a:xfrm>
-            <a:off x="5600413" y="1823802"/>
+            <a:off x="5600413" y="2318473"/>
             <a:ext cx="1948723" cy="509666"/>
           </a:xfrm>
           <a:prstGeom prst="roundRect">
@@ -13551,7 +13374,7 @@
         </p:nvSpPr>
         <p:spPr>
           <a:xfrm>
-            <a:off x="1520317" y="2470878"/>
+            <a:off x="1520317" y="2965549"/>
             <a:ext cx="1486800" cy="509666"/>
           </a:xfrm>
           <a:prstGeom prst="roundRect">
@@ -13632,7 +13455,7 @@
         </p:nvSpPr>
         <p:spPr>
           <a:xfrm>
-            <a:off x="3793103" y="2470878"/>
+            <a:off x="3793103" y="2965549"/>
             <a:ext cx="1485615" cy="509666"/>
           </a:xfrm>
           <a:prstGeom prst="roundRect">
@@ -13695,7 +13518,7 @@
         </p:nvSpPr>
         <p:spPr>
           <a:xfrm>
-            <a:off x="6063521" y="2470878"/>
+            <a:off x="6063521" y="2965549"/>
             <a:ext cx="1485615" cy="509666"/>
           </a:xfrm>
           <a:prstGeom prst="roundRect">
@@ -13758,7 +13581,7 @@
         </p:nvSpPr>
         <p:spPr>
           <a:xfrm>
-            <a:off x="6063521" y="3117954"/>
+            <a:off x="6063521" y="3612625"/>
             <a:ext cx="1485615" cy="509666"/>
           </a:xfrm>
           <a:prstGeom prst="roundRect">
@@ -13842,7 +13665,7 @@
         </p:nvCxnSpPr>
         <p:spPr>
           <a:xfrm flipH="1">
-            <a:off x="2032756" y="891916"/>
+            <a:off x="2032756" y="1386587"/>
             <a:ext cx="2270447" cy="931886"/>
           </a:xfrm>
           <a:prstGeom prst="straightConnector1">
@@ -13884,7 +13707,7 @@
         </p:nvCxnSpPr>
         <p:spPr>
           <a:xfrm>
-            <a:off x="4303203" y="891916"/>
+            <a:off x="4303203" y="1386587"/>
             <a:ext cx="562" cy="931886"/>
           </a:xfrm>
           <a:prstGeom prst="straightConnector1">
@@ -13926,7 +13749,7 @@
         </p:nvCxnSpPr>
         <p:spPr>
           <a:xfrm>
-            <a:off x="4303203" y="891916"/>
+            <a:off x="4303203" y="1386587"/>
             <a:ext cx="2271572" cy="931886"/>
           </a:xfrm>
           <a:prstGeom prst="straightConnector1">
@@ -15122,6 +14945,13 @@
                 <a:cs typeface="Courier New" panose="02070309020205020404" pitchFamily="49" charset="0"/>
               </a:rPr>
               <a:t>base_test</a:t>
+            </a:r>
+            <a:r>
+              <a:rPr lang="es-MX" sz="1200" dirty="0">
+                <a:latin typeface="Courier New" panose="02070309020205020404" pitchFamily="49" charset="0"/>
+                <a:cs typeface="Courier New" panose="02070309020205020404" pitchFamily="49" charset="0"/>
+              </a:rPr>
+              <a:t>)</a:t>
             </a:r>
             <a:endParaRPr sz="1200" dirty="0">
               <a:latin typeface="Courier New" panose="02070309020205020404" pitchFamily="49" charset="0"/>

</xml_diff>